<commit_message>
Slides: badged PPTX of sd-13-001
</commit_message>
<xml_diff>
--- a/system-design-101/vi/lessons/sd-13-001/slides/sd-13-001.pptx
+++ b/system-design-101/vi/lessons/sd-13-001/slides/sd-13-001.pptx
@@ -2935,7 +2935,7 @@
               <a:t>Traffic</a:t>
             </a:r>
             <a:r>
-              <a:rPr lang="en-US" sz="2100" dirty="0" spc="-4" kern="0">
+              <a:rPr lang="en-US" sz="2100" dirty="0" spc="-3" kern="0">
                 <a:solidFill>
                   <a:srgbClr val="7C93FF"/>
                 </a:solidFill>
@@ -2943,10 +2943,10 @@
                 <a:ea typeface="Be Vietnam Pro SemiBold" pitchFamily="34" charset="-122"/>
                 <a:cs typeface="Be Vietnam Pro SemiBold" pitchFamily="34" charset="-120"/>
               </a:rPr>
-              <a:t> còn</a:t>
-            </a:r>
-            <a:r>
-              <a:rPr lang="en-US" sz="2100" dirty="0" spc="4" kern="0">
+              <a:t> có thể</a:t>
+            </a:r>
+            <a:r>
+              <a:rPr lang="en-US" sz="2100" dirty="0" spc="-5" kern="0">
                 <a:solidFill>
                   <a:srgbClr val="7C93FF"/>
                 </a:solidFill>
@@ -2954,10 +2954,10 @@
                 <a:ea typeface="Be Vietnam Pro SemiBold" pitchFamily="34" charset="-122"/>
                 <a:cs typeface="Be Vietnam Pro SemiBold" pitchFamily="34" charset="-120"/>
               </a:rPr>
-              <a:t> đến</a:t>
-            </a:r>
-            <a:r>
-              <a:rPr lang="en-US" sz="2100" dirty="0" spc="-4" kern="0">
+              <a:t> còn</a:t>
+            </a:r>
+            <a:r>
+              <a:rPr lang="en-US" sz="2100" dirty="0" spc="4" kern="0">
                 <a:solidFill>
                   <a:srgbClr val="7C93FF"/>
                 </a:solidFill>
@@ -2965,10 +2965,10 @@
                 <a:ea typeface="Be Vietnam Pro SemiBold" pitchFamily="34" charset="-122"/>
                 <a:cs typeface="Be Vietnam Pro SemiBold" pitchFamily="34" charset="-120"/>
               </a:rPr>
-              <a:t> thêm</a:t>
-            </a:r>
-            <a:r>
-              <a:rPr lang="en-US" sz="2100" dirty="0" spc="-6" kern="0">
+              <a:t> đến</a:t>
+            </a:r>
+            <a:r>
+              <a:rPr lang="en-US" sz="2100" dirty="0" spc="-4" kern="0">
                 <a:solidFill>
                   <a:srgbClr val="7C93FF"/>
                 </a:solidFill>
@@ -2976,18 +2976,7 @@
                 <a:ea typeface="Be Vietnam Pro SemiBold" pitchFamily="34" charset="-122"/>
                 <a:cs typeface="Be Vietnam Pro SemiBold" pitchFamily="34" charset="-120"/>
               </a:rPr>
-              <a:t> một</a:t>
-            </a:r>
-            <a:r>
-              <a:rPr lang="en-US" sz="2100" dirty="0" spc="-2" kern="0">
-                <a:solidFill>
-                  <a:srgbClr val="7C93FF"/>
-                </a:solidFill>
-                <a:latin typeface="Be Vietnam Pro SemiBold" pitchFamily="34" charset="0"/>
-                <a:ea typeface="Be Vietnam Pro SemiBold" pitchFamily="34" charset="-122"/>
-                <a:cs typeface="Be Vietnam Pro SemiBold" pitchFamily="34" charset="-120"/>
-              </a:rPr>
-              <a:t> lúc</a:t>
+              <a:t> thêm</a:t>
             </a:r>
             <a:endParaRPr lang="en-US" sz="2100" dirty="0"/>
           </a:p>
@@ -8117,7 +8106,7 @@
       </p:sp>
       <p:sp>
         <p:nvSpPr>
-          <p:cNvPr id="8" name="Text richtext-1792319751846-988628887"/>
+          <p:cNvPr id="8" name="Text richtext-1792321202243-595209318"/>
           <p:cNvSpPr/>
           <p:nvPr/>
         </p:nvSpPr>
@@ -8272,6 +8261,28 @@
               <a:t> proxy</a:t>
             </a:r>
             <a:r>
+              <a:rPr lang="en-US" sz="2400" dirty="0" spc="-1" kern="0">
+                <a:solidFill>
+                  <a:srgbClr val="F3EEE3"/>
+                </a:solidFill>
+                <a:latin typeface="Be Vietnam Pro" pitchFamily="34" charset="0"/>
+                <a:ea typeface="Be Vietnam Pro" pitchFamily="34" charset="-122"/>
+                <a:cs typeface="Be Vietnam Pro" pitchFamily="34" charset="-120"/>
+              </a:rPr>
+              <a:t> có</a:t>
+            </a:r>
+            <a:r>
+              <a:rPr lang="en-US" sz="2400" dirty="0" spc="1" kern="0">
+                <a:solidFill>
+                  <a:srgbClr val="F3EEE3"/>
+                </a:solidFill>
+                <a:latin typeface="Be Vietnam Pro" pitchFamily="34" charset="0"/>
+                <a:ea typeface="Be Vietnam Pro" pitchFamily="34" charset="-122"/>
+                <a:cs typeface="Be Vietnam Pro" pitchFamily="34" charset="-120"/>
+              </a:rPr>
+              <a:t> thể</a:t>
+            </a:r>
+            <a:r>
               <a:rPr lang="en-US" sz="2400" dirty="0" spc="-12" kern="0">
                 <a:solidFill>
                   <a:srgbClr val="F3EEE3"/>
@@ -8479,7 +8490,7 @@
       </p:sp>
       <p:sp>
         <p:nvSpPr>
-          <p:cNvPr id="11" name="Connector line-1792319751872-619189719"/>
+          <p:cNvPr id="11" name="Connector line-1792321202266-908166688"/>
           <p:cNvSpPr/>
           <p:nvPr/>
         </p:nvSpPr>
@@ -8538,7 +8549,7 @@
         <p:spPr>
           <a:xfrm>
             <a:off x="10858500" y="3409950"/>
-            <a:ext cx="5334000" cy="419100"/>
+            <a:ext cx="5524500" cy="419100"/>
           </a:xfrm>
           <a:prstGeom prst="rect">
             <a:avLst/>
@@ -8585,6 +8596,50 @@
                 <a:cs typeface="Be Vietnam Pro SemiBold" pitchFamily="34" charset="-120"/>
               </a:rPr>
               <a:t> Pod</a:t>
+            </a:r>
+            <a:r>
+              <a:rPr lang="en-US" sz="1950" dirty="0" spc="-1" kern="0">
+                <a:solidFill>
+                  <a:srgbClr val="9AA0B5"/>
+                </a:solidFill>
+                <a:latin typeface="Be Vietnam Pro SemiBold" pitchFamily="34" charset="0"/>
+                <a:ea typeface="Be Vietnam Pro SemiBold" pitchFamily="34" charset="-122"/>
+                <a:cs typeface="Be Vietnam Pro SemiBold" pitchFamily="34" charset="-120"/>
+              </a:rPr>
+              <a:t> ·</a:t>
+            </a:r>
+            <a:r>
+              <a:rPr lang="en-US" sz="1950" dirty="0" spc="2" kern="0">
+                <a:solidFill>
+                  <a:srgbClr val="9AA0B5"/>
+                </a:solidFill>
+                <a:latin typeface="Be Vietnam Pro SemiBold" pitchFamily="34" charset="0"/>
+                <a:ea typeface="Be Vietnam Pro SemiBold" pitchFamily="34" charset="-122"/>
+                <a:cs typeface="Be Vietnam Pro SemiBold" pitchFamily="34" charset="-120"/>
+              </a:rPr>
+              <a:t> Service</a:t>
+            </a:r>
+            <a:r>
+              <a:rPr lang="en-US" sz="1950" dirty="0" spc="0" kern="0">
+                <a:solidFill>
+                  <a:srgbClr val="9AA0B5"/>
+                </a:solidFill>
+                <a:latin typeface="Be Vietnam Pro SemiBold" pitchFamily="34" charset="0"/>
+                <a:ea typeface="Be Vietnam Pro SemiBold" pitchFamily="34" charset="-122"/>
+                <a:cs typeface="Be Vietnam Pro SemiBold" pitchFamily="34" charset="-120"/>
+              </a:rPr>
+              <a:t> mặc</a:t>
+            </a:r>
+            <a:r>
+              <a:rPr lang="en-US" sz="1950" dirty="0" spc="10" kern="0">
+                <a:solidFill>
+                  <a:srgbClr val="9AA0B5"/>
+                </a:solidFill>
+                <a:latin typeface="Be Vietnam Pro SemiBold" pitchFamily="34" charset="0"/>
+                <a:ea typeface="Be Vietnam Pro SemiBold" pitchFamily="34" charset="-122"/>
+                <a:cs typeface="Be Vietnam Pro SemiBold" pitchFamily="34" charset="-120"/>
+              </a:rPr>
+              <a:t> định</a:t>
             </a:r>
             <a:endParaRPr lang="en-US" sz="1950" dirty="0"/>
           </a:p>
@@ -8766,7 +8821,7 @@
       </p:sp>
       <p:sp>
         <p:nvSpPr>
-          <p:cNvPr id="17" name="Connector line-1792319751880-318626040"/>
+          <p:cNvPr id="17" name="Connector line-1792321202276-776917600"/>
           <p:cNvSpPr/>
           <p:nvPr/>
         </p:nvSpPr>

</xml_diff>